<commit_message>
test: strengthen structured provenance acceptance
</commit_message>
<xml_diff>
--- a/testdata/document_intelligence/office/presentation.pptx
+++ b/testdata/document_intelligence/office/presentation.pptx
@@ -34,7 +34,12 @@
 
 <file path=ppt/slides/slide3.xml><?xml version="1.0" encoding="utf-8"?>
 <p:sld xmlns:p="p" xmlns:a="a">
-  <a:t>Slide 3 APAC</a:t>
+  <p:sp>
+    <a:t>Churn and retention</a:t>
+  </p:sp>
+  <p:sp>
+    <a:t>Churn discussion and retention actions</a:t>
+  </p:sp>
 </p:sld>
 </file>
 

</xml_diff>